<commit_message>
Simplify presentation cover and closing slide
Co-authored-by: arena-agent <297053741+arena-agent@users.noreply.github.com>
</commit_message>
<xml_diff>
--- a/documents/ubs-treasury-risk-presentation-10-slides.pptx
+++ b/documents/ubs-treasury-risk-presentation-10-slides.pptx
@@ -3778,8 +3778,8 @@
         </p:nvSpPr>
         <p:spPr>
           <a:xfrm>
-            <a:off x="2139696" y="347472"/>
-            <a:ext cx="8046720" cy="164592"/>
+            <a:off x="713232" y="1920240"/>
+            <a:ext cx="10744200" cy="603504"/>
           </a:xfrm>
           <a:prstGeom prst="rect">
             <a:avLst/>
@@ -3801,13 +3801,13 @@
               </a:spcAft>
             </a:pPr>
             <a:r>
-              <a:rPr sz="819" b="1">
-                <a:solidFill>
-                  <a:srgbClr val="68747B"/>
-                </a:solidFill>
-                <a:latin typeface="Arial"/>
-              </a:rPr>
-              <a:t>CORPORATE TREASURY MANAGEMENT  ·  2011 CASE</a:t>
+              <a:rPr sz="3100" b="1">
+                <a:solidFill>
+                  <a:srgbClr val="18232B"/>
+                </a:solidFill>
+                <a:latin typeface="Arial"/>
+              </a:rPr>
+              <a:t>UBS 2011 ROGUE TRADING SCANDAL</a:t>
             </a:r>
           </a:p>
         </p:txBody>
@@ -3820,8 +3820,8 @@
         </p:nvSpPr>
         <p:spPr>
           <a:xfrm>
-            <a:off x="621792" y="1143000"/>
-            <a:ext cx="6675120" cy="621792"/>
+            <a:off x="731520" y="2670048"/>
+            <a:ext cx="8686800" cy="320040"/>
           </a:xfrm>
           <a:prstGeom prst="rect">
             <a:avLst/>
@@ -3843,548 +3843,34 @@
               </a:spcAft>
             </a:pPr>
             <a:r>
-              <a:rPr sz="2400" b="1">
-                <a:solidFill>
-                  <a:srgbClr val="18232B"/>
-                </a:solidFill>
-                <a:latin typeface="Arial"/>
-              </a:rPr>
-              <a:t>UBS 2011 ROGUE TRADING
-SCANDAL</a:t>
-            </a:r>
-          </a:p>
-        </p:txBody>
-      </p:sp>
-      <p:sp>
-        <p:nvSpPr>
-          <p:cNvPr id="7" name="TextBox 6"/>
-          <p:cNvSpPr txBox="1"/>
-          <p:nvPr/>
-        </p:nvSpPr>
-        <p:spPr>
-          <a:xfrm>
-            <a:off x="640080" y="1865376"/>
-            <a:ext cx="6675120" cy="274320"/>
-          </a:xfrm>
-          <a:prstGeom prst="rect">
-            <a:avLst/>
-          </a:prstGeom>
-          <a:noFill/>
-        </p:spPr>
-        <p:txBody>
-          <a:bodyPr wrap="square" lIns="18288" rIns="18288" tIns="18288" bIns="18288" anchor="ctr">
-            <a:spAutoFit/>
-          </a:bodyPr>
-          <a:lstStyle/>
-          <a:p>
-            <a:pPr algn="l">
-              <a:spcBef>
-                <a:spcPts val="0"/>
-              </a:spcBef>
-              <a:spcAft>
-                <a:spcPts val="0"/>
-              </a:spcAft>
-            </a:pPr>
-            <a:r>
-              <a:rPr sz="1300" b="1">
+              <a:rPr sz="1600" b="1">
                 <a:solidFill>
                   <a:srgbClr val="C82036"/>
                 </a:solidFill>
                 <a:latin typeface="Arial"/>
               </a:rPr>
-              <a:t>FROM OPERATIONAL FAILURE TO TREASURY DECISIONS</a:t>
-            </a:r>
-          </a:p>
-        </p:txBody>
-      </p:sp>
-      <p:sp>
-        <p:nvSpPr>
-          <p:cNvPr id="8" name="Rectangle 7"/>
-          <p:cNvSpPr/>
-          <p:nvPr/>
-        </p:nvSpPr>
-        <p:spPr>
-          <a:xfrm>
-            <a:off x="621792" y="2487168"/>
-            <a:ext cx="6583680" cy="1353312"/>
-          </a:xfrm>
-          <a:prstGeom prst="rect">
-            <a:avLst/>
-          </a:prstGeom>
-          <a:solidFill>
-            <a:srgbClr val="101315"/>
-          </a:solidFill>
-          <a:ln w="10160">
-            <a:solidFill>
-              <a:srgbClr val="101315"/>
-            </a:solidFill>
-          </a:ln>
-        </p:spPr>
-        <p:style>
-          <a:lnRef idx="1">
-            <a:schemeClr val="accent1"/>
-          </a:lnRef>
-          <a:fillRef idx="3">
-            <a:schemeClr val="accent1"/>
-          </a:fillRef>
-          <a:effectRef idx="2">
-            <a:schemeClr val="accent1"/>
-          </a:effectRef>
-          <a:fontRef idx="minor">
-            <a:schemeClr val="lt1"/>
-          </a:fontRef>
-        </p:style>
-        <p:txBody>
-          <a:bodyPr rtlCol="0" anchor="ctr"/>
-          <a:lstStyle/>
-          <a:p>
-            <a:pPr algn="ctr"/>
-          </a:p>
-        </p:txBody>
-      </p:sp>
-      <p:sp>
-        <p:nvSpPr>
-          <p:cNvPr id="9" name="Rectangle 8"/>
-          <p:cNvSpPr/>
-          <p:nvPr/>
-        </p:nvSpPr>
-        <p:spPr>
-          <a:xfrm>
-            <a:off x="621792" y="2487168"/>
-            <a:ext cx="59436" cy="1353312"/>
-          </a:xfrm>
-          <a:prstGeom prst="rect">
-            <a:avLst/>
-          </a:prstGeom>
-          <a:solidFill>
-            <a:srgbClr val="008F72"/>
-          </a:solidFill>
-          <a:ln>
-            <a:noFill/>
-          </a:ln>
-        </p:spPr>
-        <p:style>
-          <a:lnRef idx="1">
-            <a:schemeClr val="accent1"/>
-          </a:lnRef>
-          <a:fillRef idx="3">
-            <a:schemeClr val="accent1"/>
-          </a:fillRef>
-          <a:effectRef idx="2">
-            <a:schemeClr val="accent1"/>
-          </a:effectRef>
-          <a:fontRef idx="minor">
-            <a:schemeClr val="lt1"/>
-          </a:fontRef>
-        </p:style>
-        <p:txBody>
-          <a:bodyPr rtlCol="0" anchor="ctr"/>
-          <a:lstStyle/>
-          <a:p>
-            <a:pPr algn="ctr"/>
-          </a:p>
-        </p:txBody>
-      </p:sp>
-      <p:sp>
-        <p:nvSpPr>
-          <p:cNvPr id="10" name="TextBox 9"/>
-          <p:cNvSpPr txBox="1"/>
-          <p:nvPr/>
-        </p:nvSpPr>
-        <p:spPr>
-          <a:xfrm>
-            <a:off x="877824" y="2651760"/>
-            <a:ext cx="6035040" cy="182880"/>
-          </a:xfrm>
-          <a:prstGeom prst="rect">
-            <a:avLst/>
-          </a:prstGeom>
-          <a:noFill/>
-        </p:spPr>
-        <p:txBody>
-          <a:bodyPr wrap="square" lIns="18288" rIns="18288" tIns="18288" bIns="18288" anchor="ctr">
-            <a:spAutoFit/>
-          </a:bodyPr>
-          <a:lstStyle/>
-          <a:p>
-            <a:pPr algn="l">
-              <a:spcBef>
-                <a:spcPts val="0"/>
-              </a:spcBef>
-              <a:spcAft>
-                <a:spcPts val="0"/>
-              </a:spcAft>
-            </a:pPr>
-            <a:r>
-              <a:rPr sz="830" b="1">
-                <a:solidFill>
-                  <a:srgbClr val="008F72"/>
-                </a:solidFill>
-                <a:latin typeface="Arial"/>
-              </a:rPr>
-              <a:t>CENTRAL TREASURY QUESTION</a:t>
-            </a:r>
-          </a:p>
-        </p:txBody>
-      </p:sp>
-      <p:sp>
-        <p:nvSpPr>
-          <p:cNvPr id="11" name="TextBox 10"/>
-          <p:cNvSpPr txBox="1"/>
-          <p:nvPr/>
-        </p:nvSpPr>
-        <p:spPr>
-          <a:xfrm>
-            <a:off x="877824" y="2907792"/>
-            <a:ext cx="5998464" cy="722376"/>
-          </a:xfrm>
-          <a:prstGeom prst="rect">
-            <a:avLst/>
-          </a:prstGeom>
-          <a:noFill/>
-        </p:spPr>
-        <p:txBody>
-          <a:bodyPr wrap="square" lIns="18288" rIns="18288" tIns="18288" bIns="18288" anchor="ctr">
-            <a:spAutoFit/>
-          </a:bodyPr>
-          <a:lstStyle/>
-          <a:p>
-            <a:pPr algn="l">
-              <a:spcBef>
-                <a:spcPts val="0"/>
-              </a:spcBef>
-              <a:spcAft>
-                <a:spcPts val="0"/>
-              </a:spcAft>
-            </a:pPr>
-            <a:r>
-              <a:rPr sz="1550" b="1">
-                <a:solidFill>
-                  <a:srgbClr val="FFFFFF"/>
-                </a:solidFill>
-                <a:latin typeface="Arial"/>
-              </a:rPr>
-              <a:t>How should UBS Treasury preserve liquidity and meet payment obligations over the following three months?</a:t>
-            </a:r>
-          </a:p>
-        </p:txBody>
-      </p:sp>
-      <p:sp>
-        <p:nvSpPr>
-          <p:cNvPr id="12" name="Rectangle 11"/>
-          <p:cNvSpPr/>
-          <p:nvPr/>
-        </p:nvSpPr>
-        <p:spPr>
-          <a:xfrm>
-            <a:off x="7516368" y="1197864"/>
-            <a:ext cx="4178808" cy="2642616"/>
-          </a:xfrm>
-          <a:prstGeom prst="rect">
-            <a:avLst/>
-          </a:prstGeom>
-          <a:solidFill>
-            <a:srgbClr val="FFFFFF"/>
-          </a:solidFill>
-          <a:ln w="10160">
-            <a:solidFill>
-              <a:srgbClr val="C9CECB"/>
-            </a:solidFill>
-          </a:ln>
-        </p:spPr>
-        <p:style>
-          <a:lnRef idx="1">
-            <a:schemeClr val="accent1"/>
-          </a:lnRef>
-          <a:fillRef idx="3">
-            <a:schemeClr val="accent1"/>
-          </a:fillRef>
-          <a:effectRef idx="2">
-            <a:schemeClr val="accent1"/>
-          </a:effectRef>
-          <a:fontRef idx="minor">
-            <a:schemeClr val="lt1"/>
-          </a:fontRef>
-        </p:style>
-        <p:txBody>
-          <a:bodyPr rtlCol="0" anchor="ctr"/>
-          <a:lstStyle/>
-          <a:p>
-            <a:pPr algn="ctr"/>
-          </a:p>
-        </p:txBody>
-      </p:sp>
-      <p:sp>
-        <p:nvSpPr>
-          <p:cNvPr id="13" name="Rectangle 12"/>
-          <p:cNvSpPr/>
-          <p:nvPr/>
-        </p:nvSpPr>
-        <p:spPr>
-          <a:xfrm>
-            <a:off x="7516368" y="1197864"/>
-            <a:ext cx="4178808" cy="50292"/>
-          </a:xfrm>
-          <a:prstGeom prst="rect">
-            <a:avLst/>
-          </a:prstGeom>
-          <a:solidFill>
-            <a:srgbClr val="C82036"/>
-          </a:solidFill>
-          <a:ln>
-            <a:noFill/>
-          </a:ln>
-        </p:spPr>
-        <p:style>
-          <a:lnRef idx="1">
-            <a:schemeClr val="accent1"/>
-          </a:lnRef>
-          <a:fillRef idx="3">
-            <a:schemeClr val="accent1"/>
-          </a:fillRef>
-          <a:effectRef idx="2">
-            <a:schemeClr val="accent1"/>
-          </a:effectRef>
-          <a:fontRef idx="minor">
-            <a:schemeClr val="lt1"/>
-          </a:fontRef>
-        </p:style>
-        <p:txBody>
-          <a:bodyPr rtlCol="0" anchor="ctr"/>
-          <a:lstStyle/>
-          <a:p>
-            <a:pPr algn="ctr"/>
-          </a:p>
-        </p:txBody>
-      </p:sp>
-      <p:sp>
-        <p:nvSpPr>
-          <p:cNvPr id="14" name="TextBox 13"/>
-          <p:cNvSpPr txBox="1"/>
-          <p:nvPr/>
-        </p:nvSpPr>
-        <p:spPr>
-          <a:xfrm>
-            <a:off x="7754112" y="1444752"/>
-            <a:ext cx="3675887" cy="219456"/>
-          </a:xfrm>
-          <a:prstGeom prst="rect">
-            <a:avLst/>
-          </a:prstGeom>
-          <a:noFill/>
-        </p:spPr>
-        <p:txBody>
-          <a:bodyPr wrap="square" lIns="18288" rIns="18288" tIns="18288" bIns="18288" anchor="ctr">
-            <a:spAutoFit/>
-          </a:bodyPr>
-          <a:lstStyle/>
-          <a:p>
-            <a:pPr algn="l">
-              <a:spcBef>
-                <a:spcPts val="0"/>
-              </a:spcBef>
-              <a:spcAft>
-                <a:spcPts val="0"/>
-              </a:spcAft>
-            </a:pPr>
-            <a:r>
-              <a:rPr sz="919" b="1">
-                <a:solidFill>
-                  <a:srgbClr val="18232B"/>
-                </a:solidFill>
-                <a:latin typeface="Arial"/>
-              </a:rPr>
-              <a:t>THE TREASURY RESPONSE</a:t>
-            </a:r>
-          </a:p>
-        </p:txBody>
-      </p:sp>
-      <p:sp>
-        <p:nvSpPr>
-          <p:cNvPr id="15" name="Oval 14"/>
-          <p:cNvSpPr/>
-          <p:nvPr/>
-        </p:nvSpPr>
-        <p:spPr>
-          <a:xfrm>
-            <a:off x="7763256" y="1828800"/>
-            <a:ext cx="384048" cy="384048"/>
-          </a:xfrm>
-          <a:prstGeom prst="ellipse">
-            <a:avLst/>
-          </a:prstGeom>
-          <a:solidFill>
-            <a:srgbClr val="C82036"/>
-          </a:solidFill>
-          <a:ln>
-            <a:noFill/>
-          </a:ln>
-        </p:spPr>
-        <p:style>
-          <a:lnRef idx="1">
-            <a:schemeClr val="accent1"/>
-          </a:lnRef>
-          <a:fillRef idx="3">
-            <a:schemeClr val="accent1"/>
-          </a:fillRef>
-          <a:effectRef idx="2">
-            <a:schemeClr val="accent1"/>
-          </a:effectRef>
-          <a:fontRef idx="minor">
-            <a:schemeClr val="lt1"/>
-          </a:fontRef>
-        </p:style>
-        <p:txBody>
-          <a:bodyPr rtlCol="0" anchor="ctr"/>
-          <a:lstStyle/>
-          <a:p>
-            <a:pPr algn="ctr"/>
-          </a:p>
-        </p:txBody>
-      </p:sp>
-      <p:sp>
-        <p:nvSpPr>
-          <p:cNvPr id="16" name="TextBox 15"/>
-          <p:cNvSpPr txBox="1"/>
-          <p:nvPr/>
-        </p:nvSpPr>
-        <p:spPr>
-          <a:xfrm>
-            <a:off x="7763256" y="1920240"/>
-            <a:ext cx="384048" cy="182880"/>
-          </a:xfrm>
-          <a:prstGeom prst="rect">
-            <a:avLst/>
-          </a:prstGeom>
-          <a:noFill/>
-        </p:spPr>
-        <p:txBody>
-          <a:bodyPr wrap="square" lIns="18288" rIns="18288" tIns="18288" bIns="18288" anchor="ctr">
-            <a:spAutoFit/>
-          </a:bodyPr>
-          <a:lstStyle/>
-          <a:p>
-            <a:pPr algn="ctr">
-              <a:spcBef>
-                <a:spcPts val="0"/>
-              </a:spcBef>
-              <a:spcAft>
-                <a:spcPts val="0"/>
-              </a:spcAft>
-            </a:pPr>
-            <a:r>
-              <a:rPr sz="740" b="1">
-                <a:solidFill>
-                  <a:srgbClr val="FFFFFF"/>
-                </a:solidFill>
-                <a:latin typeface="Arial"/>
-              </a:rPr>
-              <a:t>01</a:t>
-            </a:r>
-          </a:p>
-        </p:txBody>
-      </p:sp>
-      <p:sp>
-        <p:nvSpPr>
-          <p:cNvPr id="17" name="TextBox 16"/>
-          <p:cNvSpPr txBox="1"/>
-          <p:nvPr/>
-        </p:nvSpPr>
-        <p:spPr>
-          <a:xfrm>
-            <a:off x="8321040" y="1837943"/>
-            <a:ext cx="1325880" cy="182880"/>
-          </a:xfrm>
-          <a:prstGeom prst="rect">
-            <a:avLst/>
-          </a:prstGeom>
-          <a:noFill/>
-        </p:spPr>
-        <p:txBody>
-          <a:bodyPr wrap="square" lIns="18288" rIns="18288" tIns="18288" bIns="18288" anchor="ctr">
-            <a:spAutoFit/>
-          </a:bodyPr>
-          <a:lstStyle/>
-          <a:p>
-            <a:pPr algn="l">
-              <a:spcBef>
-                <a:spcPts val="0"/>
-              </a:spcBef>
-              <a:spcAft>
-                <a:spcPts val="0"/>
-              </a:spcAft>
-            </a:pPr>
-            <a:r>
-              <a:rPr sz="900" b="1">
-                <a:solidFill>
-                  <a:srgbClr val="C82036"/>
-                </a:solidFill>
-                <a:latin typeface="Arial"/>
-              </a:rPr>
-              <a:t>VERIFY</a:t>
-            </a:r>
-          </a:p>
-        </p:txBody>
-      </p:sp>
-      <p:sp>
-        <p:nvSpPr>
-          <p:cNvPr id="18" name="TextBox 17"/>
-          <p:cNvSpPr txBox="1"/>
-          <p:nvPr/>
-        </p:nvSpPr>
-        <p:spPr>
-          <a:xfrm>
-            <a:off x="9692640" y="1837943"/>
-            <a:ext cx="1618488" cy="182880"/>
-          </a:xfrm>
-          <a:prstGeom prst="rect">
-            <a:avLst/>
-          </a:prstGeom>
-          <a:noFill/>
-        </p:spPr>
-        <p:txBody>
-          <a:bodyPr wrap="square" lIns="18288" rIns="18288" tIns="18288" bIns="18288" anchor="ctr">
-            <a:spAutoFit/>
-          </a:bodyPr>
-          <a:lstStyle/>
-          <a:p>
-            <a:pPr algn="l">
-              <a:spcBef>
-                <a:spcPts val="0"/>
-              </a:spcBef>
-              <a:spcAft>
-                <a:spcPts val="0"/>
-              </a:spcAft>
-            </a:pPr>
-            <a:r>
-              <a:rPr sz="840" b="1">
-                <a:solidFill>
-                  <a:srgbClr val="18232B"/>
-                </a:solidFill>
-                <a:latin typeface="Arial"/>
-              </a:rPr>
-              <a:t>Positions</a:t>
+              <a:t>Treasury Risk Analysis</a:t>
             </a:r>
           </a:p>
         </p:txBody>
       </p:sp>
       <p:cxnSp>
         <p:nvCxnSpPr>
-          <p:cNvPr id="19" name="Connector 18"/>
+          <p:cNvPr id="7" name="Connector 6"/>
           <p:cNvCxnSpPr/>
           <p:nvPr/>
         </p:nvCxnSpPr>
         <p:spPr>
           <a:xfrm>
-            <a:off x="7955279" y="2221992"/>
-            <a:ext cx="0" cy="182880"/>
+            <a:off x="731520" y="3246120"/>
+            <a:ext cx="1325880" cy="0"/>
           </a:xfrm>
           <a:prstGeom prst="line">
             <a:avLst/>
           </a:prstGeom>
-          <a:ln w="15240">
+          <a:ln w="27940">
             <a:solidFill>
-              <a:srgbClr val="C9CECB"/>
+              <a:srgbClr val="C82036"/>
             </a:solidFill>
           </a:ln>
         </p:spPr>
@@ -4405,57 +3891,14 @@
       </p:cxnSp>
       <p:sp>
         <p:nvSpPr>
-          <p:cNvPr id="20" name="Oval 19"/>
-          <p:cNvSpPr/>
-          <p:nvPr/>
-        </p:nvSpPr>
-        <p:spPr>
-          <a:xfrm>
-            <a:off x="7763256" y="2432304"/>
-            <a:ext cx="384048" cy="384048"/>
-          </a:xfrm>
-          <a:prstGeom prst="ellipse">
-            <a:avLst/>
-          </a:prstGeom>
-          <a:solidFill>
-            <a:srgbClr val="C49500"/>
-          </a:solidFill>
-          <a:ln>
-            <a:noFill/>
-          </a:ln>
-        </p:spPr>
-        <p:style>
-          <a:lnRef idx="1">
-            <a:schemeClr val="accent1"/>
-          </a:lnRef>
-          <a:fillRef idx="3">
-            <a:schemeClr val="accent1"/>
-          </a:fillRef>
-          <a:effectRef idx="2">
-            <a:schemeClr val="accent1"/>
-          </a:effectRef>
-          <a:fontRef idx="minor">
-            <a:schemeClr val="lt1"/>
-          </a:fontRef>
-        </p:style>
-        <p:txBody>
-          <a:bodyPr rtlCol="0" anchor="ctr"/>
-          <a:lstStyle/>
-          <a:p>
-            <a:pPr algn="ctr"/>
-          </a:p>
-        </p:txBody>
-      </p:sp>
-      <p:sp>
-        <p:nvSpPr>
-          <p:cNvPr id="21" name="TextBox 20"/>
-          <p:cNvSpPr txBox="1"/>
-          <p:nvPr/>
-        </p:nvSpPr>
-        <p:spPr>
-          <a:xfrm>
-            <a:off x="7763256" y="2523744"/>
-            <a:ext cx="384048" cy="182880"/>
+          <p:cNvPr id="8" name="TextBox 7"/>
+          <p:cNvSpPr txBox="1"/>
+          <p:nvPr/>
+        </p:nvSpPr>
+        <p:spPr>
+          <a:xfrm>
+            <a:off x="731520" y="4160520"/>
+            <a:ext cx="1828800" cy="164592"/>
           </a:xfrm>
           <a:prstGeom prst="rect">
             <a:avLst/>
@@ -4468,36 +3911,36 @@
           </a:bodyPr>
           <a:lstStyle/>
           <a:p>
-            <a:pPr algn="ctr">
-              <a:spcBef>
-                <a:spcPts val="0"/>
-              </a:spcBef>
-              <a:spcAft>
-                <a:spcPts val="0"/>
-              </a:spcAft>
-            </a:pPr>
-            <a:r>
-              <a:rPr sz="740" b="1">
-                <a:solidFill>
-                  <a:srgbClr val="FFFFFF"/>
-                </a:solidFill>
-                <a:latin typeface="Arial"/>
-              </a:rPr>
-              <a:t>02</a:t>
-            </a:r>
-          </a:p>
-        </p:txBody>
-      </p:sp>
-      <p:sp>
-        <p:nvSpPr>
-          <p:cNvPr id="22" name="TextBox 21"/>
-          <p:cNvSpPr txBox="1"/>
-          <p:nvPr/>
-        </p:nvSpPr>
-        <p:spPr>
-          <a:xfrm>
-            <a:off x="8321040" y="2441448"/>
-            <a:ext cx="1325880" cy="182880"/>
+            <a:pPr algn="l">
+              <a:spcBef>
+                <a:spcPts val="0"/>
+              </a:spcBef>
+              <a:spcAft>
+                <a:spcPts val="0"/>
+              </a:spcAft>
+            </a:pPr>
+            <a:r>
+              <a:rPr sz="800" b="1">
+                <a:solidFill>
+                  <a:srgbClr val="68747B"/>
+                </a:solidFill>
+                <a:latin typeface="Arial"/>
+              </a:rPr>
+              <a:t>PRESENTED BY</a:t>
+            </a:r>
+          </a:p>
+        </p:txBody>
+      </p:sp>
+      <p:sp>
+        <p:nvSpPr>
+          <p:cNvPr id="9" name="TextBox 8"/>
+          <p:cNvSpPr txBox="1"/>
+          <p:nvPr/>
+        </p:nvSpPr>
+        <p:spPr>
+          <a:xfrm>
+            <a:off x="731520" y="4425696"/>
+            <a:ext cx="10652760" cy="292608"/>
           </a:xfrm>
           <a:prstGeom prst="rect">
             <a:avLst/>
@@ -4519,27 +3962,27 @@
               </a:spcAft>
             </a:pPr>
             <a:r>
-              <a:rPr sz="900" b="1">
-                <a:solidFill>
-                  <a:srgbClr val="C49500"/>
-                </a:solidFill>
-                <a:latin typeface="Arial"/>
-              </a:rPr>
-              <a:t>PROTECT</a:t>
-            </a:r>
-          </a:p>
-        </p:txBody>
-      </p:sp>
-      <p:sp>
-        <p:nvSpPr>
-          <p:cNvPr id="23" name="TextBox 22"/>
-          <p:cNvSpPr txBox="1"/>
-          <p:nvPr/>
-        </p:nvSpPr>
-        <p:spPr>
-          <a:xfrm>
-            <a:off x="9692640" y="2441448"/>
-            <a:ext cx="1618488" cy="182880"/>
+              <a:rPr sz="1200" b="1">
+                <a:solidFill>
+                  <a:srgbClr val="18232B"/>
+                </a:solidFill>
+                <a:latin typeface="Arial"/>
+              </a:rPr>
+              <a:t>Paul Alain Diouf  ·  Calvin Minang  ·  Jules Métayer  ·  Elias Abou-Tayeh</a:t>
+            </a:r>
+          </a:p>
+        </p:txBody>
+      </p:sp>
+      <p:sp>
+        <p:nvSpPr>
+          <p:cNvPr id="10" name="TextBox 9"/>
+          <p:cNvSpPr txBox="1"/>
+          <p:nvPr/>
+        </p:nvSpPr>
+        <p:spPr>
+          <a:xfrm>
+            <a:off x="731520" y="5029200"/>
+            <a:ext cx="1828800" cy="164592"/>
           </a:xfrm>
           <a:prstGeom prst="rect">
             <a:avLst/>
@@ -4561,710 +4004,55 @@
               </a:spcAft>
             </a:pPr>
             <a:r>
-              <a:rPr sz="840" b="1">
+              <a:rPr sz="800" b="1">
+                <a:solidFill>
+                  <a:srgbClr val="68747B"/>
+                </a:solidFill>
+                <a:latin typeface="Arial"/>
+              </a:rPr>
+              <a:t>PROFESSOR</a:t>
+            </a:r>
+          </a:p>
+        </p:txBody>
+      </p:sp>
+      <p:sp>
+        <p:nvSpPr>
+          <p:cNvPr id="11" name="TextBox 10"/>
+          <p:cNvSpPr txBox="1"/>
+          <p:nvPr/>
+        </p:nvSpPr>
+        <p:spPr>
+          <a:xfrm>
+            <a:off x="731520" y="5285232"/>
+            <a:ext cx="4754880" cy="274320"/>
+          </a:xfrm>
+          <a:prstGeom prst="rect">
+            <a:avLst/>
+          </a:prstGeom>
+          <a:noFill/>
+        </p:spPr>
+        <p:txBody>
+          <a:bodyPr wrap="square" lIns="18288" rIns="18288" tIns="18288" bIns="18288" anchor="ctr">
+            <a:spAutoFit/>
+          </a:bodyPr>
+          <a:lstStyle/>
+          <a:p>
+            <a:pPr algn="l">
+              <a:spcBef>
+                <a:spcPts val="0"/>
+              </a:spcBef>
+              <a:spcAft>
+                <a:spcPts val="0"/>
+              </a:spcAft>
+            </a:pPr>
+            <a:r>
+              <a:rPr sz="1200" b="1">
                 <a:solidFill>
                   <a:srgbClr val="18232B"/>
                 </a:solidFill>
                 <a:latin typeface="Arial"/>
               </a:rPr>
-              <a:t>Headroom</a:t>
-            </a:r>
-          </a:p>
-        </p:txBody>
-      </p:sp>
-      <p:cxnSp>
-        <p:nvCxnSpPr>
-          <p:cNvPr id="24" name="Connector 23"/>
-          <p:cNvCxnSpPr/>
-          <p:nvPr/>
-        </p:nvCxnSpPr>
-        <p:spPr>
-          <a:xfrm>
-            <a:off x="7955279" y="2825496"/>
-            <a:ext cx="0" cy="182880"/>
-          </a:xfrm>
-          <a:prstGeom prst="line">
-            <a:avLst/>
-          </a:prstGeom>
-          <a:ln w="15240">
-            <a:solidFill>
-              <a:srgbClr val="C9CECB"/>
-            </a:solidFill>
-          </a:ln>
-        </p:spPr>
-        <p:style>
-          <a:lnRef idx="2">
-            <a:schemeClr val="accent1"/>
-          </a:lnRef>
-          <a:fillRef idx="0">
-            <a:schemeClr val="accent1"/>
-          </a:fillRef>
-          <a:effectRef idx="1">
-            <a:schemeClr val="accent1"/>
-          </a:effectRef>
-          <a:fontRef idx="minor">
-            <a:schemeClr val="tx1"/>
-          </a:fontRef>
-        </p:style>
-      </p:cxnSp>
-      <p:sp>
-        <p:nvSpPr>
-          <p:cNvPr id="25" name="Oval 24"/>
-          <p:cNvSpPr/>
-          <p:nvPr/>
-        </p:nvSpPr>
-        <p:spPr>
-          <a:xfrm>
-            <a:off x="7763256" y="3035808"/>
-            <a:ext cx="384048" cy="384048"/>
-          </a:xfrm>
-          <a:prstGeom prst="ellipse">
-            <a:avLst/>
-          </a:prstGeom>
-          <a:solidFill>
-            <a:srgbClr val="008F72"/>
-          </a:solidFill>
-          <a:ln>
-            <a:noFill/>
-          </a:ln>
-        </p:spPr>
-        <p:style>
-          <a:lnRef idx="1">
-            <a:schemeClr val="accent1"/>
-          </a:lnRef>
-          <a:fillRef idx="3">
-            <a:schemeClr val="accent1"/>
-          </a:fillRef>
-          <a:effectRef idx="2">
-            <a:schemeClr val="accent1"/>
-          </a:effectRef>
-          <a:fontRef idx="minor">
-            <a:schemeClr val="lt1"/>
-          </a:fontRef>
-        </p:style>
-        <p:txBody>
-          <a:bodyPr rtlCol="0" anchor="ctr"/>
-          <a:lstStyle/>
-          <a:p>
-            <a:pPr algn="ctr"/>
-          </a:p>
-        </p:txBody>
-      </p:sp>
-      <p:sp>
-        <p:nvSpPr>
-          <p:cNvPr id="26" name="TextBox 25"/>
-          <p:cNvSpPr txBox="1"/>
-          <p:nvPr/>
-        </p:nvSpPr>
-        <p:spPr>
-          <a:xfrm>
-            <a:off x="7763256" y="3127248"/>
-            <a:ext cx="384048" cy="182880"/>
-          </a:xfrm>
-          <a:prstGeom prst="rect">
-            <a:avLst/>
-          </a:prstGeom>
-          <a:noFill/>
-        </p:spPr>
-        <p:txBody>
-          <a:bodyPr wrap="square" lIns="18288" rIns="18288" tIns="18288" bIns="18288" anchor="ctr">
-            <a:spAutoFit/>
-          </a:bodyPr>
-          <a:lstStyle/>
-          <a:p>
-            <a:pPr algn="ctr">
-              <a:spcBef>
-                <a:spcPts val="0"/>
-              </a:spcBef>
-              <a:spcAft>
-                <a:spcPts val="0"/>
-              </a:spcAft>
-            </a:pPr>
-            <a:r>
-              <a:rPr sz="740" b="1">
-                <a:solidFill>
-                  <a:srgbClr val="FFFFFF"/>
-                </a:solidFill>
-                <a:latin typeface="Arial"/>
-              </a:rPr>
-              <a:t>03</a:t>
-            </a:r>
-          </a:p>
-        </p:txBody>
-      </p:sp>
-      <p:sp>
-        <p:nvSpPr>
-          <p:cNvPr id="27" name="TextBox 26"/>
-          <p:cNvSpPr txBox="1"/>
-          <p:nvPr/>
-        </p:nvSpPr>
-        <p:spPr>
-          <a:xfrm>
-            <a:off x="8321040" y="3044952"/>
-            <a:ext cx="1325880" cy="182880"/>
-          </a:xfrm>
-          <a:prstGeom prst="rect">
-            <a:avLst/>
-          </a:prstGeom>
-          <a:noFill/>
-        </p:spPr>
-        <p:txBody>
-          <a:bodyPr wrap="square" lIns="18288" rIns="18288" tIns="18288" bIns="18288" anchor="ctr">
-            <a:spAutoFit/>
-          </a:bodyPr>
-          <a:lstStyle/>
-          <a:p>
-            <a:pPr algn="l">
-              <a:spcBef>
-                <a:spcPts val="0"/>
-              </a:spcBef>
-              <a:spcAft>
-                <a:spcPts val="0"/>
-              </a:spcAft>
-            </a:pPr>
-            <a:r>
-              <a:rPr sz="900" b="1">
-                <a:solidFill>
-                  <a:srgbClr val="008F72"/>
-                </a:solidFill>
-                <a:latin typeface="Arial"/>
-              </a:rPr>
-              <a:t>STAGE</a:t>
-            </a:r>
-          </a:p>
-        </p:txBody>
-      </p:sp>
-      <p:sp>
-        <p:nvSpPr>
-          <p:cNvPr id="28" name="TextBox 27"/>
-          <p:cNvSpPr txBox="1"/>
-          <p:nvPr/>
-        </p:nvSpPr>
-        <p:spPr>
-          <a:xfrm>
-            <a:off x="9692640" y="3044952"/>
-            <a:ext cx="1618488" cy="182880"/>
-          </a:xfrm>
-          <a:prstGeom prst="rect">
-            <a:avLst/>
-          </a:prstGeom>
-          <a:noFill/>
-        </p:spPr>
-        <p:txBody>
-          <a:bodyPr wrap="square" lIns="18288" rIns="18288" tIns="18288" bIns="18288" anchor="ctr">
-            <a:spAutoFit/>
-          </a:bodyPr>
-          <a:lstStyle/>
-          <a:p>
-            <a:pPr algn="l">
-              <a:spcBef>
-                <a:spcPts val="0"/>
-              </a:spcBef>
-              <a:spcAft>
-                <a:spcPts val="0"/>
-              </a:spcAft>
-            </a:pPr>
-            <a:r>
-              <a:rPr sz="840" b="1">
-                <a:solidFill>
-                  <a:srgbClr val="18232B"/>
-                </a:solidFill>
-                <a:latin typeface="Arial"/>
-              </a:rPr>
-              <a:t>Funding</a:t>
-            </a:r>
-          </a:p>
-        </p:txBody>
-      </p:sp>
-      <p:cxnSp>
-        <p:nvCxnSpPr>
-          <p:cNvPr id="29" name="Connector 28"/>
-          <p:cNvCxnSpPr/>
-          <p:nvPr/>
-        </p:nvCxnSpPr>
-        <p:spPr>
-          <a:xfrm>
-            <a:off x="621792" y="4251960"/>
-            <a:ext cx="11064240" cy="0"/>
-          </a:xfrm>
-          <a:prstGeom prst="line">
-            <a:avLst/>
-          </a:prstGeom>
-          <a:ln w="10160">
-            <a:solidFill>
-              <a:srgbClr val="C9CECB"/>
-            </a:solidFill>
-          </a:ln>
-        </p:spPr>
-        <p:style>
-          <a:lnRef idx="2">
-            <a:schemeClr val="accent1"/>
-          </a:lnRef>
-          <a:fillRef idx="0">
-            <a:schemeClr val="accent1"/>
-          </a:fillRef>
-          <a:effectRef idx="1">
-            <a:schemeClr val="accent1"/>
-          </a:effectRef>
-          <a:fontRef idx="minor">
-            <a:schemeClr val="tx1"/>
-          </a:fontRef>
-        </p:style>
-      </p:cxnSp>
-      <p:sp>
-        <p:nvSpPr>
-          <p:cNvPr id="30" name="TextBox 29"/>
-          <p:cNvSpPr txBox="1"/>
-          <p:nvPr/>
-        </p:nvSpPr>
-        <p:spPr>
-          <a:xfrm>
-            <a:off x="658368" y="4489704"/>
-            <a:ext cx="1280160" cy="182880"/>
-          </a:xfrm>
-          <a:prstGeom prst="rect">
-            <a:avLst/>
-          </a:prstGeom>
-          <a:noFill/>
-        </p:spPr>
-        <p:txBody>
-          <a:bodyPr wrap="square" lIns="18288" rIns="18288" tIns="18288" bIns="18288" anchor="ctr">
-            <a:spAutoFit/>
-          </a:bodyPr>
-          <a:lstStyle/>
-          <a:p>
-            <a:pPr algn="l">
-              <a:spcBef>
-                <a:spcPts val="0"/>
-              </a:spcBef>
-              <a:spcAft>
-                <a:spcPts val="0"/>
-              </a:spcAft>
-            </a:pPr>
-            <a:r>
-              <a:rPr sz="780" b="1">
-                <a:solidFill>
-                  <a:srgbClr val="C82036"/>
-                </a:solidFill>
-                <a:latin typeface="Arial"/>
-              </a:rPr>
-              <a:t>PRESENTERS</a:t>
-            </a:r>
-          </a:p>
-        </p:txBody>
-      </p:sp>
-      <p:sp>
-        <p:nvSpPr>
-          <p:cNvPr id="31" name="TextBox 30"/>
-          <p:cNvSpPr txBox="1"/>
-          <p:nvPr/>
-        </p:nvSpPr>
-        <p:spPr>
-          <a:xfrm>
-            <a:off x="1993392" y="4453128"/>
-            <a:ext cx="9418320" cy="274320"/>
-          </a:xfrm>
-          <a:prstGeom prst="rect">
-            <a:avLst/>
-          </a:prstGeom>
-          <a:noFill/>
-        </p:spPr>
-        <p:txBody>
-          <a:bodyPr wrap="square" lIns="18288" rIns="18288" tIns="18288" bIns="18288" anchor="ctr">
-            <a:spAutoFit/>
-          </a:bodyPr>
-          <a:lstStyle/>
-          <a:p>
-            <a:pPr algn="l">
-              <a:spcBef>
-                <a:spcPts val="0"/>
-              </a:spcBef>
-              <a:spcAft>
-                <a:spcPts val="0"/>
-              </a:spcAft>
-            </a:pPr>
-            <a:r>
-              <a:rPr sz="1030" b="1">
-                <a:solidFill>
-                  <a:srgbClr val="18232B"/>
-                </a:solidFill>
-                <a:latin typeface="Arial"/>
-              </a:rPr>
-              <a:t>Paul Alain Diouf  ·  Calvin Minang  ·  Jules Métayer  ·  Elias Abou-Tayeh</a:t>
-            </a:r>
-          </a:p>
-        </p:txBody>
-      </p:sp>
-      <p:sp>
-        <p:nvSpPr>
-          <p:cNvPr id="32" name="TextBox 31"/>
-          <p:cNvSpPr txBox="1"/>
-          <p:nvPr/>
-        </p:nvSpPr>
-        <p:spPr>
-          <a:xfrm>
-            <a:off x="658368" y="4965192"/>
-            <a:ext cx="1719072" cy="182880"/>
-          </a:xfrm>
-          <a:prstGeom prst="rect">
-            <a:avLst/>
-          </a:prstGeom>
-          <a:noFill/>
-        </p:spPr>
-        <p:txBody>
-          <a:bodyPr wrap="square" lIns="18288" rIns="18288" tIns="18288" bIns="18288" anchor="ctr">
-            <a:spAutoFit/>
-          </a:bodyPr>
-          <a:lstStyle/>
-          <a:p>
-            <a:pPr algn="l">
-              <a:spcBef>
-                <a:spcPts val="0"/>
-              </a:spcBef>
-              <a:spcAft>
-                <a:spcPts val="0"/>
-              </a:spcAft>
-            </a:pPr>
-            <a:r>
-              <a:rPr sz="780" b="1">
-                <a:solidFill>
-                  <a:srgbClr val="C82036"/>
-                </a:solidFill>
-                <a:latin typeface="Arial"/>
-              </a:rPr>
-              <a:t>ACADEMIC SUPERVISOR</a:t>
-            </a:r>
-          </a:p>
-        </p:txBody>
-      </p:sp>
-      <p:sp>
-        <p:nvSpPr>
-          <p:cNvPr id="33" name="TextBox 32"/>
-          <p:cNvSpPr txBox="1"/>
-          <p:nvPr/>
-        </p:nvSpPr>
-        <p:spPr>
-          <a:xfrm>
-            <a:off x="2414016" y="4928616"/>
-            <a:ext cx="2926080" cy="274320"/>
-          </a:xfrm>
-          <a:prstGeom prst="rect">
-            <a:avLst/>
-          </a:prstGeom>
-          <a:noFill/>
-        </p:spPr>
-        <p:txBody>
-          <a:bodyPr wrap="square" lIns="18288" rIns="18288" tIns="18288" bIns="18288" anchor="ctr">
-            <a:spAutoFit/>
-          </a:bodyPr>
-          <a:lstStyle/>
-          <a:p>
-            <a:pPr algn="l">
-              <a:spcBef>
-                <a:spcPts val="0"/>
-              </a:spcBef>
-              <a:spcAft>
-                <a:spcPts val="0"/>
-              </a:spcAft>
-            </a:pPr>
-            <a:r>
-              <a:rPr sz="1000" b="1">
-                <a:solidFill>
-                  <a:srgbClr val="18232B"/>
-                </a:solidFill>
-                <a:latin typeface="Arial"/>
-              </a:rPr>
               <a:t>Jamil Chaftar</a:t>
-            </a:r>
-          </a:p>
-        </p:txBody>
-      </p:sp>
-      <p:sp>
-        <p:nvSpPr>
-          <p:cNvPr id="34" name="Rectangle 33"/>
-          <p:cNvSpPr/>
-          <p:nvPr/>
-        </p:nvSpPr>
-        <p:spPr>
-          <a:xfrm>
-            <a:off x="640080" y="5513832"/>
-            <a:ext cx="11036808" cy="640080"/>
-          </a:xfrm>
-          <a:prstGeom prst="rect">
-            <a:avLst/>
-          </a:prstGeom>
-          <a:solidFill>
-            <a:srgbClr val="E8ECE8"/>
-          </a:solidFill>
-          <a:ln>
-            <a:noFill/>
-          </a:ln>
-        </p:spPr>
-        <p:style>
-          <a:lnRef idx="1">
-            <a:schemeClr val="accent1"/>
-          </a:lnRef>
-          <a:fillRef idx="3">
-            <a:schemeClr val="accent1"/>
-          </a:fillRef>
-          <a:effectRef idx="2">
-            <a:schemeClr val="accent1"/>
-          </a:effectRef>
-          <a:fontRef idx="minor">
-            <a:schemeClr val="lt1"/>
-          </a:fontRef>
-        </p:style>
-        <p:txBody>
-          <a:bodyPr rtlCol="0" anchor="ctr"/>
-          <a:lstStyle/>
-          <a:p>
-            <a:pPr algn="ctr"/>
-          </a:p>
-        </p:txBody>
-      </p:sp>
-      <p:sp>
-        <p:nvSpPr>
-          <p:cNvPr id="35" name="TextBox 34"/>
-          <p:cNvSpPr txBox="1"/>
-          <p:nvPr/>
-        </p:nvSpPr>
-        <p:spPr>
-          <a:xfrm>
-            <a:off x="850392" y="5623560"/>
-            <a:ext cx="1490472" cy="164592"/>
-          </a:xfrm>
-          <a:prstGeom prst="rect">
-            <a:avLst/>
-          </a:prstGeom>
-          <a:noFill/>
-        </p:spPr>
-        <p:txBody>
-          <a:bodyPr wrap="square" lIns="18288" rIns="18288" tIns="18288" bIns="18288" anchor="ctr">
-            <a:spAutoFit/>
-          </a:bodyPr>
-          <a:lstStyle/>
-          <a:p>
-            <a:pPr algn="l">
-              <a:spcBef>
-                <a:spcPts val="0"/>
-              </a:spcBef>
-              <a:spcAft>
-                <a:spcPts val="0"/>
-              </a:spcAft>
-            </a:pPr>
-            <a:r>
-              <a:rPr sz="750" b="1">
-                <a:solidFill>
-                  <a:srgbClr val="68747B"/>
-                </a:solidFill>
-                <a:latin typeface="Arial"/>
-              </a:rPr>
-              <a:t>DECISION WINDOW</a:t>
-            </a:r>
-          </a:p>
-        </p:txBody>
-      </p:sp>
-      <p:sp>
-        <p:nvSpPr>
-          <p:cNvPr id="36" name="TextBox 35"/>
-          <p:cNvSpPr txBox="1"/>
-          <p:nvPr/>
-        </p:nvSpPr>
-        <p:spPr>
-          <a:xfrm>
-            <a:off x="2468880" y="5605272"/>
-            <a:ext cx="2423160" cy="182880"/>
-          </a:xfrm>
-          <a:prstGeom prst="rect">
-            <a:avLst/>
-          </a:prstGeom>
-          <a:noFill/>
-        </p:spPr>
-        <p:txBody>
-          <a:bodyPr wrap="square" lIns="18288" rIns="18288" tIns="18288" bIns="18288" anchor="ctr">
-            <a:spAutoFit/>
-          </a:bodyPr>
-          <a:lstStyle/>
-          <a:p>
-            <a:pPr algn="l">
-              <a:spcBef>
-                <a:spcPts val="0"/>
-              </a:spcBef>
-              <a:spcAft>
-                <a:spcPts val="0"/>
-              </a:spcAft>
-            </a:pPr>
-            <a:r>
-              <a:rPr sz="819" b="1">
-                <a:solidFill>
-                  <a:srgbClr val="18232B"/>
-                </a:solidFill>
-                <a:latin typeface="Arial"/>
-              </a:rPr>
-              <a:t>14 SEP 2011  ·  DISCOVERY</a:t>
-            </a:r>
-          </a:p>
-        </p:txBody>
-      </p:sp>
-      <p:cxnSp>
-        <p:nvCxnSpPr>
-          <p:cNvPr id="37" name="Connector 36"/>
-          <p:cNvCxnSpPr/>
-          <p:nvPr/>
-        </p:nvCxnSpPr>
-        <p:spPr>
-          <a:xfrm>
-            <a:off x="4956048" y="5715000"/>
-            <a:ext cx="3858768" cy="0"/>
-          </a:xfrm>
-          <a:prstGeom prst="line">
-            <a:avLst/>
-          </a:prstGeom>
-          <a:ln w="25400">
-            <a:solidFill>
-              <a:srgbClr val="008F72"/>
-            </a:solidFill>
-          </a:ln>
-        </p:spPr>
-        <p:style>
-          <a:lnRef idx="2">
-            <a:schemeClr val="accent1"/>
-          </a:lnRef>
-          <a:fillRef idx="0">
-            <a:schemeClr val="accent1"/>
-          </a:fillRef>
-          <a:effectRef idx="1">
-            <a:schemeClr val="accent1"/>
-          </a:effectRef>
-          <a:fontRef idx="minor">
-            <a:schemeClr val="tx1"/>
-          </a:fontRef>
-        </p:style>
-      </p:cxnSp>
-      <p:sp>
-        <p:nvSpPr>
-          <p:cNvPr id="38" name="Oval 37"/>
-          <p:cNvSpPr/>
-          <p:nvPr/>
-        </p:nvSpPr>
-        <p:spPr>
-          <a:xfrm>
-            <a:off x="4901184" y="5641848"/>
-            <a:ext cx="146304" cy="146304"/>
-          </a:xfrm>
-          <a:prstGeom prst="ellipse">
-            <a:avLst/>
-          </a:prstGeom>
-          <a:solidFill>
-            <a:srgbClr val="008F72"/>
-          </a:solidFill>
-          <a:ln>
-            <a:noFill/>
-          </a:ln>
-        </p:spPr>
-        <p:style>
-          <a:lnRef idx="1">
-            <a:schemeClr val="accent1"/>
-          </a:lnRef>
-          <a:fillRef idx="3">
-            <a:schemeClr val="accent1"/>
-          </a:fillRef>
-          <a:effectRef idx="2">
-            <a:schemeClr val="accent1"/>
-          </a:effectRef>
-          <a:fontRef idx="minor">
-            <a:schemeClr val="lt1"/>
-          </a:fontRef>
-        </p:style>
-        <p:txBody>
-          <a:bodyPr rtlCol="0" anchor="ctr"/>
-          <a:lstStyle/>
-          <a:p>
-            <a:pPr algn="ctr"/>
-          </a:p>
-        </p:txBody>
-      </p:sp>
-      <p:sp>
-        <p:nvSpPr>
-          <p:cNvPr id="39" name="Oval 38"/>
-          <p:cNvSpPr/>
-          <p:nvPr/>
-        </p:nvSpPr>
-        <p:spPr>
-          <a:xfrm>
-            <a:off x="8741664" y="5641848"/>
-            <a:ext cx="146304" cy="146304"/>
-          </a:xfrm>
-          <a:prstGeom prst="ellipse">
-            <a:avLst/>
-          </a:prstGeom>
-          <a:solidFill>
-            <a:srgbClr val="C82036"/>
-          </a:solidFill>
-          <a:ln>
-            <a:noFill/>
-          </a:ln>
-        </p:spPr>
-        <p:style>
-          <a:lnRef idx="1">
-            <a:schemeClr val="accent1"/>
-          </a:lnRef>
-          <a:fillRef idx="3">
-            <a:schemeClr val="accent1"/>
-          </a:fillRef>
-          <a:effectRef idx="2">
-            <a:schemeClr val="accent1"/>
-          </a:effectRef>
-          <a:fontRef idx="minor">
-            <a:schemeClr val="lt1"/>
-          </a:fontRef>
-        </p:style>
-        <p:txBody>
-          <a:bodyPr rtlCol="0" anchor="ctr"/>
-          <a:lstStyle/>
-          <a:p>
-            <a:pPr algn="ctr"/>
-          </a:p>
-        </p:txBody>
-      </p:sp>
-      <p:sp>
-        <p:nvSpPr>
-          <p:cNvPr id="40" name="TextBox 39"/>
-          <p:cNvSpPr txBox="1"/>
-          <p:nvPr/>
-        </p:nvSpPr>
-        <p:spPr>
-          <a:xfrm>
-            <a:off x="8988552" y="5605272"/>
-            <a:ext cx="2432304" cy="182880"/>
-          </a:xfrm>
-          <a:prstGeom prst="rect">
-            <a:avLst/>
-          </a:prstGeom>
-          <a:noFill/>
-        </p:spPr>
-        <p:txBody>
-          <a:bodyPr wrap="square" lIns="18288" rIns="18288" tIns="18288" bIns="18288" anchor="ctr">
-            <a:spAutoFit/>
-          </a:bodyPr>
-          <a:lstStyle/>
-          <a:p>
-            <a:pPr algn="l">
-              <a:spcBef>
-                <a:spcPts val="0"/>
-              </a:spcBef>
-              <a:spcAft>
-                <a:spcPts val="0"/>
-              </a:spcAft>
-            </a:pPr>
-            <a:r>
-              <a:rPr sz="819" b="1">
-                <a:solidFill>
-                  <a:srgbClr val="18232B"/>
-                </a:solidFill>
-                <a:latin typeface="Arial"/>
-              </a:rPr>
-              <a:t>14 DEC 2011  ·  END OF HORIZON</a:t>
             </a:r>
           </a:p>
         </p:txBody>
@@ -5356,7 +4144,7 @@
                 </a:solidFill>
                 <a:latin typeface="Arial"/>
               </a:rPr>
-              <a:t>CONCLUSION &amp; SOURCES</a:t>
+              <a:t/>
             </a:r>
           </a:p>
         </p:txBody>
@@ -5398,7 +4186,7 @@
                 </a:solidFill>
                 <a:latin typeface="Arial"/>
               </a:rPr>
-              <a:t>THE TREASURY DECISION</a:t>
+              <a:t/>
             </a:r>
           </a:p>
         </p:txBody>
@@ -5440,7 +4228,7 @@
                 </a:solidFill>
                 <a:latin typeface="Arial"/>
               </a:rPr>
-              <a:t>PROTECT PAYMENT CAPACITY · VERIFY POSITIONS · GATE FUNDING</a:t>
+              <a:t/>
             </a:r>
           </a:p>
         </p:txBody>
@@ -5583,102 +4371,14 @@
       </p:sp>
       <p:sp>
         <p:nvSpPr>
-          <p:cNvPr id="10" name="Rectangle 9"/>
-          <p:cNvSpPr/>
-          <p:nvPr/>
-        </p:nvSpPr>
-        <p:spPr>
-          <a:xfrm>
-            <a:off x="621792" y="1252728"/>
-            <a:ext cx="10954512" cy="1243584"/>
-          </a:xfrm>
-          <a:prstGeom prst="rect">
-            <a:avLst/>
-          </a:prstGeom>
-          <a:solidFill>
-            <a:srgbClr val="101315"/>
-          </a:solidFill>
-          <a:ln w="10160">
-            <a:solidFill>
-              <a:srgbClr val="101315"/>
-            </a:solidFill>
-          </a:ln>
-        </p:spPr>
-        <p:style>
-          <a:lnRef idx="1">
-            <a:schemeClr val="accent1"/>
-          </a:lnRef>
-          <a:fillRef idx="3">
-            <a:schemeClr val="accent1"/>
-          </a:fillRef>
-          <a:effectRef idx="2">
-            <a:schemeClr val="accent1"/>
-          </a:effectRef>
-          <a:fontRef idx="minor">
-            <a:schemeClr val="lt1"/>
-          </a:fontRef>
-        </p:style>
-        <p:txBody>
-          <a:bodyPr rtlCol="0" anchor="ctr"/>
-          <a:lstStyle/>
-          <a:p>
-            <a:pPr algn="ctr"/>
-          </a:p>
-        </p:txBody>
-      </p:sp>
-      <p:sp>
-        <p:nvSpPr>
-          <p:cNvPr id="11" name="Rectangle 10"/>
-          <p:cNvSpPr/>
-          <p:nvPr/>
-        </p:nvSpPr>
-        <p:spPr>
-          <a:xfrm>
-            <a:off x="621792" y="1252728"/>
-            <a:ext cx="59436" cy="1243584"/>
-          </a:xfrm>
-          <a:prstGeom prst="rect">
-            <a:avLst/>
-          </a:prstGeom>
-          <a:solidFill>
-            <a:srgbClr val="C82036"/>
-          </a:solidFill>
-          <a:ln>
-            <a:noFill/>
-          </a:ln>
-        </p:spPr>
-        <p:style>
-          <a:lnRef idx="1">
-            <a:schemeClr val="accent1"/>
-          </a:lnRef>
-          <a:fillRef idx="3">
-            <a:schemeClr val="accent1"/>
-          </a:fillRef>
-          <a:effectRef idx="2">
-            <a:schemeClr val="accent1"/>
-          </a:effectRef>
-          <a:fontRef idx="minor">
-            <a:schemeClr val="lt1"/>
-          </a:fontRef>
-        </p:style>
-        <p:txBody>
-          <a:bodyPr rtlCol="0" anchor="ctr"/>
-          <a:lstStyle/>
-          <a:p>
-            <a:pPr algn="ctr"/>
-          </a:p>
-        </p:txBody>
-      </p:sp>
-      <p:sp>
-        <p:nvSpPr>
-          <p:cNvPr id="12" name="TextBox 11"/>
-          <p:cNvSpPr txBox="1"/>
-          <p:nvPr/>
-        </p:nvSpPr>
-        <p:spPr>
-          <a:xfrm>
-            <a:off x="896112" y="1444752"/>
-            <a:ext cx="1828800" cy="182880"/>
+          <p:cNvPr id="10" name="TextBox 9"/>
+          <p:cNvSpPr txBox="1"/>
+          <p:nvPr/>
+        </p:nvSpPr>
+        <p:spPr>
+          <a:xfrm>
+            <a:off x="694944" y="1353312"/>
+            <a:ext cx="10789920" cy="658368"/>
           </a:xfrm>
           <a:prstGeom prst="rect">
             <a:avLst/>
@@ -5700,27 +4400,27 @@
               </a:spcAft>
             </a:pPr>
             <a:r>
-              <a:rPr sz="819" b="1">
-                <a:solidFill>
-                  <a:srgbClr val="008F72"/>
-                </a:solidFill>
-                <a:latin typeface="Arial"/>
-              </a:rPr>
-              <a:t>CENTRAL ANSWER</a:t>
-            </a:r>
-          </a:p>
-        </p:txBody>
-      </p:sp>
-      <p:sp>
-        <p:nvSpPr>
-          <p:cNvPr id="13" name="TextBox 12"/>
-          <p:cNvSpPr txBox="1"/>
-          <p:nvPr/>
-        </p:nvSpPr>
-        <p:spPr>
-          <a:xfrm>
-            <a:off x="896112" y="1719072"/>
-            <a:ext cx="10332720" cy="530352"/>
+              <a:rPr sz="3400" b="1">
+                <a:solidFill>
+                  <a:srgbClr val="18232B"/>
+                </a:solidFill>
+                <a:latin typeface="Arial"/>
+              </a:rPr>
+              <a:t>Thank you</a:t>
+            </a:r>
+          </a:p>
+        </p:txBody>
+      </p:sp>
+      <p:sp>
+        <p:nvSpPr>
+          <p:cNvPr id="11" name="TextBox 10"/>
+          <p:cNvSpPr txBox="1"/>
+          <p:nvPr/>
+        </p:nvSpPr>
+        <p:spPr>
+          <a:xfrm>
+            <a:off x="713232" y="2468880"/>
+            <a:ext cx="1828800" cy="201168"/>
           </a:xfrm>
           <a:prstGeom prst="rect">
             <a:avLst/>
@@ -5742,76 +4442,34 @@
               </a:spcAft>
             </a:pPr>
             <a:r>
-              <a:rPr sz="1400" b="1">
-                <a:solidFill>
-                  <a:srgbClr val="FFFFFF"/>
-                </a:solidFill>
-                <a:latin typeface="Arial"/>
-              </a:rPr>
-              <a:t>Preserve headroom: reconcile positions, forecast accessible cash by entity, currency and value date, then stage only verified funding before a projected buffer breach.</a:t>
-            </a:r>
-          </a:p>
-        </p:txBody>
-      </p:sp>
-      <p:sp>
-        <p:nvSpPr>
-          <p:cNvPr id="14" name="TextBox 13"/>
-          <p:cNvSpPr txBox="1"/>
-          <p:nvPr/>
-        </p:nvSpPr>
-        <p:spPr>
-          <a:xfrm>
-            <a:off x="658368" y="2761488"/>
-            <a:ext cx="2743200" cy="219456"/>
-          </a:xfrm>
-          <a:prstGeom prst="rect">
-            <a:avLst/>
-          </a:prstGeom>
-          <a:noFill/>
-        </p:spPr>
-        <p:txBody>
-          <a:bodyPr wrap="square" lIns="18288" rIns="18288" tIns="18288" bIns="18288" anchor="ctr">
-            <a:spAutoFit/>
-          </a:bodyPr>
-          <a:lstStyle/>
-          <a:p>
-            <a:pPr algn="l">
-              <a:spcBef>
-                <a:spcPts val="0"/>
-              </a:spcBef>
-              <a:spcAft>
-                <a:spcPts val="0"/>
-              </a:spcAft>
-            </a:pPr>
-            <a:r>
               <a:rPr sz="950" b="1">
                 <a:solidFill>
-                  <a:srgbClr val="18232B"/>
-                </a:solidFill>
-                <a:latin typeface="Arial"/>
-              </a:rPr>
-              <a:t>PRIMARY SOURCES</a:t>
+                  <a:srgbClr val="C82036"/>
+                </a:solidFill>
+                <a:latin typeface="Arial"/>
+              </a:rPr>
+              <a:t>SOURCES</a:t>
             </a:r>
           </a:p>
         </p:txBody>
       </p:sp>
       <p:cxnSp>
         <p:nvCxnSpPr>
-          <p:cNvPr id="15" name="Connector 14"/>
+          <p:cNvPr id="12" name="Connector 11"/>
           <p:cNvCxnSpPr/>
           <p:nvPr/>
         </p:nvCxnSpPr>
         <p:spPr>
           <a:xfrm>
-            <a:off x="658368" y="3054096"/>
-            <a:ext cx="10881360" cy="0"/>
+            <a:off x="713232" y="2770632"/>
+            <a:ext cx="10789920" cy="0"/>
           </a:xfrm>
           <a:prstGeom prst="line">
             <a:avLst/>
           </a:prstGeom>
-          <a:ln w="20320">
+          <a:ln w="12700">
             <a:solidFill>
-              <a:srgbClr val="C82036"/>
+              <a:srgbClr val="C9CECB"/>
             </a:solidFill>
           </a:ln>
         </p:spPr>
@@ -5832,14 +4490,14 @@
       </p:cxnSp>
       <p:sp>
         <p:nvSpPr>
-          <p:cNvPr id="16" name="TextBox 15"/>
-          <p:cNvSpPr txBox="1"/>
-          <p:nvPr/>
-        </p:nvSpPr>
-        <p:spPr>
-          <a:xfrm>
-            <a:off x="713232" y="3264408"/>
-            <a:ext cx="5074920" cy="192024"/>
+          <p:cNvPr id="13" name="TextBox 12"/>
+          <p:cNvSpPr txBox="1"/>
+          <p:nvPr/>
+        </p:nvSpPr>
+        <p:spPr>
+          <a:xfrm>
+            <a:off x="731520" y="3127248"/>
+            <a:ext cx="10652760" cy="292608"/>
           </a:xfrm>
           <a:prstGeom prst="rect">
             <a:avLst/>
@@ -5861,74 +4519,32 @@
               </a:spcAft>
             </a:pPr>
             <a:r>
-              <a:rPr sz="810" b="1">
-                <a:solidFill>
-                  <a:srgbClr val="C82036"/>
-                </a:solidFill>
-                <a:latin typeface="Arial"/>
-              </a:rPr>
-              <a:t>01  FINMA · 21 NOV 2012</a:t>
-            </a:r>
-          </a:p>
-        </p:txBody>
-      </p:sp>
-      <p:sp>
-        <p:nvSpPr>
-          <p:cNvPr id="17" name="TextBox 16"/>
-          <p:cNvSpPr txBox="1"/>
-          <p:nvPr/>
-        </p:nvSpPr>
-        <p:spPr>
-          <a:xfrm>
-            <a:off x="713232" y="3511296"/>
-            <a:ext cx="5074920" cy="365760"/>
-          </a:xfrm>
-          <a:prstGeom prst="rect">
-            <a:avLst/>
-          </a:prstGeom>
-          <a:noFill/>
-        </p:spPr>
-        <p:txBody>
-          <a:bodyPr wrap="square" lIns="18288" rIns="18288" tIns="18288" bIns="18288" anchor="ctr">
-            <a:spAutoFit/>
-          </a:bodyPr>
-          <a:lstStyle/>
-          <a:p>
-            <a:pPr algn="l">
-              <a:spcBef>
-                <a:spcPts val="0"/>
-              </a:spcBef>
-              <a:spcAft>
-                <a:spcPts val="0"/>
-              </a:spcAft>
-            </a:pPr>
-            <a:r>
-              <a:rPr sz="850" b="0">
+              <a:rPr sz="1019" b="0">
                 <a:solidFill>
                   <a:srgbClr val="18232B"/>
                 </a:solidFill>
                 <a:latin typeface="Arial"/>
               </a:rPr>
-              <a:t>Summary Report: investigation into UBS London trading losses.</a:t>
+              <a:t>FINMA, Summary Report: Investigation into UBS London Trading Losses, 21 November 2012.</a:t>
             </a:r>
           </a:p>
         </p:txBody>
       </p:sp>
       <p:cxnSp>
         <p:nvCxnSpPr>
-          <p:cNvPr id="18" name="Connector 17"/>
+          <p:cNvPr id="14" name="Connector 13"/>
           <p:cNvCxnSpPr/>
           <p:nvPr/>
         </p:nvCxnSpPr>
         <p:spPr>
           <a:xfrm>
-            <a:off x="713232" y="3977639"/>
-            <a:ext cx="5074920" cy="0"/>
+            <a:off x="731520" y="3520440"/>
+            <a:ext cx="10652760" cy="0"/>
           </a:xfrm>
           <a:prstGeom prst="line">
             <a:avLst/>
           </a:prstGeom>
-          <a:ln w="7620">
+          <a:ln w="6985">
             <a:solidFill>
               <a:srgbClr val="C9CECB"/>
             </a:solidFill>
@@ -5951,14 +4567,14 @@
       </p:cxnSp>
       <p:sp>
         <p:nvSpPr>
-          <p:cNvPr id="19" name="TextBox 18"/>
-          <p:cNvSpPr txBox="1"/>
-          <p:nvPr/>
-        </p:nvSpPr>
-        <p:spPr>
-          <a:xfrm>
-            <a:off x="6236208" y="3264408"/>
-            <a:ext cx="5074920" cy="192024"/>
+          <p:cNvPr id="15" name="TextBox 14"/>
+          <p:cNvSpPr txBox="1"/>
+          <p:nvPr/>
+        </p:nvSpPr>
+        <p:spPr>
+          <a:xfrm>
+            <a:off x="731520" y="3703320"/>
+            <a:ext cx="10652760" cy="292608"/>
           </a:xfrm>
           <a:prstGeom prst="rect">
             <a:avLst/>
@@ -5980,74 +4596,32 @@
               </a:spcAft>
             </a:pPr>
             <a:r>
-              <a:rPr sz="810" b="1">
-                <a:solidFill>
-                  <a:srgbClr val="C49500"/>
-                </a:solidFill>
-                <a:latin typeface="Arial"/>
-              </a:rPr>
-              <a:t>02  FSA · 25 NOV 2012</a:t>
-            </a:r>
-          </a:p>
-        </p:txBody>
-      </p:sp>
-      <p:sp>
-        <p:nvSpPr>
-          <p:cNvPr id="20" name="TextBox 19"/>
-          <p:cNvSpPr txBox="1"/>
-          <p:nvPr/>
-        </p:nvSpPr>
-        <p:spPr>
-          <a:xfrm>
-            <a:off x="6236208" y="3511296"/>
-            <a:ext cx="5074920" cy="365760"/>
-          </a:xfrm>
-          <a:prstGeom prst="rect">
-            <a:avLst/>
-          </a:prstGeom>
-          <a:noFill/>
-        </p:spPr>
-        <p:txBody>
-          <a:bodyPr wrap="square" lIns="18288" rIns="18288" tIns="18288" bIns="18288" anchor="ctr">
-            <a:spAutoFit/>
-          </a:bodyPr>
-          <a:lstStyle/>
-          <a:p>
-            <a:pPr algn="l">
-              <a:spcBef>
-                <a:spcPts val="0"/>
-              </a:spcBef>
-              <a:spcAft>
-                <a:spcPts val="0"/>
-              </a:spcAft>
-            </a:pPr>
-            <a:r>
-              <a:rPr sz="850" b="0">
+              <a:rPr sz="1019" b="0">
                 <a:solidFill>
                   <a:srgbClr val="18232B"/>
                 </a:solidFill>
                 <a:latin typeface="Arial"/>
               </a:rPr>
-              <a:t>Final Notice to UBS AG: unauthorised trading and control failures.</a:t>
+              <a:t>FSA, Final Notice to UBS AG, 25 November 2012.</a:t>
             </a:r>
           </a:p>
         </p:txBody>
       </p:sp>
       <p:cxnSp>
         <p:nvCxnSpPr>
-          <p:cNvPr id="21" name="Connector 20"/>
+          <p:cNvPr id="16" name="Connector 15"/>
           <p:cNvCxnSpPr/>
           <p:nvPr/>
         </p:nvCxnSpPr>
         <p:spPr>
           <a:xfrm>
-            <a:off x="6236208" y="3977639"/>
-            <a:ext cx="5074920" cy="0"/>
+            <a:off x="731520" y="4096511"/>
+            <a:ext cx="10652760" cy="0"/>
           </a:xfrm>
           <a:prstGeom prst="line">
             <a:avLst/>
           </a:prstGeom>
-          <a:ln w="7620">
+          <a:ln w="6985">
             <a:solidFill>
               <a:srgbClr val="C9CECB"/>
             </a:solidFill>
@@ -6070,14 +4644,14 @@
       </p:cxnSp>
       <p:sp>
         <p:nvSpPr>
-          <p:cNvPr id="22" name="TextBox 21"/>
-          <p:cNvSpPr txBox="1"/>
-          <p:nvPr/>
-        </p:nvSpPr>
-        <p:spPr>
-          <a:xfrm>
-            <a:off x="713232" y="4169663"/>
-            <a:ext cx="5074920" cy="192024"/>
+          <p:cNvPr id="17" name="TextBox 16"/>
+          <p:cNvSpPr txBox="1"/>
+          <p:nvPr/>
+        </p:nvSpPr>
+        <p:spPr>
+          <a:xfrm>
+            <a:off x="731520" y="4279392"/>
+            <a:ext cx="10652760" cy="292608"/>
           </a:xfrm>
           <a:prstGeom prst="rect">
             <a:avLst/>
@@ -6099,74 +4673,32 @@
               </a:spcAft>
             </a:pPr>
             <a:r>
-              <a:rPr sz="810" b="1">
-                <a:solidFill>
-                  <a:srgbClr val="287FA8"/>
-                </a:solidFill>
-                <a:latin typeface="Arial"/>
-              </a:rPr>
-              <a:t>03  UBS · 11 OCT 2011</a:t>
-            </a:r>
-          </a:p>
-        </p:txBody>
-      </p:sp>
-      <p:sp>
-        <p:nvSpPr>
-          <p:cNvPr id="23" name="TextBox 22"/>
-          <p:cNvSpPr txBox="1"/>
-          <p:nvPr/>
-        </p:nvSpPr>
-        <p:spPr>
-          <a:xfrm>
-            <a:off x="713232" y="4416552"/>
-            <a:ext cx="5074920" cy="365760"/>
-          </a:xfrm>
-          <a:prstGeom prst="rect">
-            <a:avLst/>
-          </a:prstGeom>
-          <a:noFill/>
-        </p:spPr>
-        <p:txBody>
-          <a:bodyPr wrap="square" lIns="18288" rIns="18288" tIns="18288" bIns="18288" anchor="ctr">
-            <a:spAutoFit/>
-          </a:bodyPr>
-          <a:lstStyle/>
-          <a:p>
-            <a:pPr algn="l">
-              <a:spcBef>
-                <a:spcPts val="0"/>
-              </a:spcBef>
-              <a:spcAft>
-                <a:spcPts val="0"/>
-              </a:spcAft>
-            </a:pPr>
-            <a:r>
-              <a:rPr sz="850" b="0">
+              <a:rPr sz="1019" b="0">
                 <a:solidFill>
                   <a:srgbClr val="18232B"/>
                 </a:solidFill>
                 <a:latin typeface="Arial"/>
               </a:rPr>
-              <a:t>Supplement No. 2: incident disclosures and loss estimate updates.</a:t>
+              <a:t>UBS, Supplement No. 2, 11 October 2011.</a:t>
             </a:r>
           </a:p>
         </p:txBody>
       </p:sp>
       <p:cxnSp>
         <p:nvCxnSpPr>
-          <p:cNvPr id="24" name="Connector 23"/>
+          <p:cNvPr id="18" name="Connector 17"/>
           <p:cNvCxnSpPr/>
           <p:nvPr/>
         </p:nvCxnSpPr>
         <p:spPr>
           <a:xfrm>
-            <a:off x="713232" y="4882896"/>
-            <a:ext cx="5074920" cy="0"/>
+            <a:off x="731520" y="4672583"/>
+            <a:ext cx="10652760" cy="0"/>
           </a:xfrm>
           <a:prstGeom prst="line">
             <a:avLst/>
           </a:prstGeom>
-          <a:ln w="7620">
+          <a:ln w="6985">
             <a:solidFill>
               <a:srgbClr val="C9CECB"/>
             </a:solidFill>
@@ -6189,14 +4721,14 @@
       </p:cxnSp>
       <p:sp>
         <p:nvSpPr>
-          <p:cNvPr id="25" name="TextBox 24"/>
-          <p:cNvSpPr txBox="1"/>
-          <p:nvPr/>
-        </p:nvSpPr>
-        <p:spPr>
-          <a:xfrm>
-            <a:off x="6236208" y="4169663"/>
-            <a:ext cx="5074920" cy="192024"/>
+          <p:cNvPr id="19" name="TextBox 18"/>
+          <p:cNvSpPr txBox="1"/>
+          <p:nvPr/>
+        </p:nvSpPr>
+        <p:spPr>
+          <a:xfrm>
+            <a:off x="731520" y="4855464"/>
+            <a:ext cx="10652760" cy="292608"/>
           </a:xfrm>
           <a:prstGeom prst="rect">
             <a:avLst/>
@@ -6218,259 +4750,13 @@
               </a:spcAft>
             </a:pPr>
             <a:r>
-              <a:rPr sz="810" b="1">
-                <a:solidFill>
-                  <a:srgbClr val="008F72"/>
-                </a:solidFill>
-                <a:latin typeface="Arial"/>
-              </a:rPr>
-              <a:t>04  UBS · 25 OCT 2011</a:t>
-            </a:r>
-          </a:p>
-        </p:txBody>
-      </p:sp>
-      <p:sp>
-        <p:nvSpPr>
-          <p:cNvPr id="26" name="TextBox 25"/>
-          <p:cNvSpPr txBox="1"/>
-          <p:nvPr/>
-        </p:nvSpPr>
-        <p:spPr>
-          <a:xfrm>
-            <a:off x="6236208" y="4416552"/>
-            <a:ext cx="5074920" cy="365760"/>
-          </a:xfrm>
-          <a:prstGeom prst="rect">
-            <a:avLst/>
-          </a:prstGeom>
-          <a:noFill/>
-        </p:spPr>
-        <p:txBody>
-          <a:bodyPr wrap="square" lIns="18288" rIns="18288" tIns="18288" bIns="18288" anchor="ctr">
-            <a:spAutoFit/>
-          </a:bodyPr>
-          <a:lstStyle/>
-          <a:p>
-            <a:pPr algn="l">
-              <a:spcBef>
-                <a:spcPts val="0"/>
-              </a:spcBef>
-              <a:spcAft>
-                <a:spcPts val="0"/>
-              </a:spcAft>
-            </a:pPr>
-            <a:r>
-              <a:rPr sz="850" b="0">
+              <a:rPr sz="1019" b="0">
                 <a:solidFill>
                   <a:srgbClr val="18232B"/>
                 </a:solidFill>
                 <a:latin typeface="Arial"/>
               </a:rPr>
-              <a:t>Third-quarter 2011 results and presentation materials.</a:t>
-            </a:r>
-          </a:p>
-        </p:txBody>
-      </p:sp>
-      <p:cxnSp>
-        <p:nvCxnSpPr>
-          <p:cNvPr id="27" name="Connector 26"/>
-          <p:cNvCxnSpPr/>
-          <p:nvPr/>
-        </p:nvCxnSpPr>
-        <p:spPr>
-          <a:xfrm>
-            <a:off x="6236208" y="4882896"/>
-            <a:ext cx="5074920" cy="0"/>
-          </a:xfrm>
-          <a:prstGeom prst="line">
-            <a:avLst/>
-          </a:prstGeom>
-          <a:ln w="7620">
-            <a:solidFill>
-              <a:srgbClr val="C9CECB"/>
-            </a:solidFill>
-          </a:ln>
-        </p:spPr>
-        <p:style>
-          <a:lnRef idx="2">
-            <a:schemeClr val="accent1"/>
-          </a:lnRef>
-          <a:fillRef idx="0">
-            <a:schemeClr val="accent1"/>
-          </a:fillRef>
-          <a:effectRef idx="1">
-            <a:schemeClr val="accent1"/>
-          </a:effectRef>
-          <a:fontRef idx="minor">
-            <a:schemeClr val="tx1"/>
-          </a:fontRef>
-        </p:style>
-      </p:cxnSp>
-      <p:sp>
-        <p:nvSpPr>
-          <p:cNvPr id="28" name="Rectangle 27"/>
-          <p:cNvSpPr/>
-          <p:nvPr/>
-        </p:nvSpPr>
-        <p:spPr>
-          <a:xfrm>
-            <a:off x="658368" y="5175504"/>
-            <a:ext cx="10881360" cy="713232"/>
-          </a:xfrm>
-          <a:prstGeom prst="rect">
-            <a:avLst/>
-          </a:prstGeom>
-          <a:solidFill>
-            <a:srgbClr val="F8F0D9"/>
-          </a:solidFill>
-          <a:ln>
-            <a:noFill/>
-          </a:ln>
-        </p:spPr>
-        <p:style>
-          <a:lnRef idx="1">
-            <a:schemeClr val="accent1"/>
-          </a:lnRef>
-          <a:fillRef idx="3">
-            <a:schemeClr val="accent1"/>
-          </a:fillRef>
-          <a:effectRef idx="2">
-            <a:schemeClr val="accent1"/>
-          </a:effectRef>
-          <a:fontRef idx="minor">
-            <a:schemeClr val="lt1"/>
-          </a:fontRef>
-        </p:style>
-        <p:txBody>
-          <a:bodyPr rtlCol="0" anchor="ctr"/>
-          <a:lstStyle/>
-          <a:p>
-            <a:pPr algn="ctr"/>
-          </a:p>
-        </p:txBody>
-      </p:sp>
-      <p:sp>
-        <p:nvSpPr>
-          <p:cNvPr id="29" name="TextBox 28"/>
-          <p:cNvSpPr txBox="1"/>
-          <p:nvPr/>
-        </p:nvSpPr>
-        <p:spPr>
-          <a:xfrm>
-            <a:off x="877824" y="5330952"/>
-            <a:ext cx="1051560" cy="164592"/>
-          </a:xfrm>
-          <a:prstGeom prst="rect">
-            <a:avLst/>
-          </a:prstGeom>
-          <a:noFill/>
-        </p:spPr>
-        <p:txBody>
-          <a:bodyPr wrap="square" lIns="18288" rIns="18288" tIns="18288" bIns="18288" anchor="ctr">
-            <a:spAutoFit/>
-          </a:bodyPr>
-          <a:lstStyle/>
-          <a:p>
-            <a:pPr algn="l">
-              <a:spcBef>
-                <a:spcPts val="0"/>
-              </a:spcBef>
-              <a:spcAft>
-                <a:spcPts val="0"/>
-              </a:spcAft>
-            </a:pPr>
-            <a:r>
-              <a:rPr sz="780" b="1">
-                <a:solidFill>
-                  <a:srgbClr val="C49500"/>
-                </a:solidFill>
-                <a:latin typeface="Arial"/>
-              </a:rPr>
-              <a:t>MODEL LIMIT</a:t>
-            </a:r>
-          </a:p>
-        </p:txBody>
-      </p:sp>
-      <p:sp>
-        <p:nvSpPr>
-          <p:cNvPr id="30" name="TextBox 29"/>
-          <p:cNvSpPr txBox="1"/>
-          <p:nvPr/>
-        </p:nvSpPr>
-        <p:spPr>
-          <a:xfrm>
-            <a:off x="1984248" y="5285232"/>
-            <a:ext cx="9281160" cy="384048"/>
-          </a:xfrm>
-          <a:prstGeom prst="rect">
-            <a:avLst/>
-          </a:prstGeom>
-          <a:noFill/>
-        </p:spPr>
-        <p:txBody>
-          <a:bodyPr wrap="square" lIns="18288" rIns="18288" tIns="18288" bIns="18288" anchor="ctr">
-            <a:spAutoFit/>
-          </a:bodyPr>
-          <a:lstStyle/>
-          <a:p>
-            <a:pPr algn="l">
-              <a:spcBef>
-                <a:spcPts val="0"/>
-              </a:spcBef>
-              <a:spcAft>
-                <a:spcPts val="0"/>
-              </a:spcAft>
-            </a:pPr>
-            <a:r>
-              <a:rPr sz="840" b="1">
-                <a:solidFill>
-                  <a:srgbClr val="18232B"/>
-                </a:solidFill>
-                <a:latin typeface="Arial"/>
-              </a:rPr>
-              <a:t>Opening cash, minimum buffer, receipts, payments, collateral, stress shocks and facility timing are illustrative assumptions—not UBS historical Treasury records.</a:t>
-            </a:r>
-          </a:p>
-        </p:txBody>
-      </p:sp>
-      <p:sp>
-        <p:nvSpPr>
-          <p:cNvPr id="31" name="TextBox 30"/>
-          <p:cNvSpPr txBox="1"/>
-          <p:nvPr/>
-        </p:nvSpPr>
-        <p:spPr>
-          <a:xfrm>
-            <a:off x="676656" y="6053328"/>
-            <a:ext cx="10927080" cy="201168"/>
-          </a:xfrm>
-          <a:prstGeom prst="rect">
-            <a:avLst/>
-          </a:prstGeom>
-          <a:noFill/>
-        </p:spPr>
-        <p:txBody>
-          <a:bodyPr wrap="square" lIns="18288" rIns="18288" tIns="18288" bIns="18288" anchor="ctr">
-            <a:spAutoFit/>
-          </a:bodyPr>
-          <a:lstStyle/>
-          <a:p>
-            <a:pPr algn="l">
-              <a:spcBef>
-                <a:spcPts val="0"/>
-              </a:spcBef>
-              <a:spcAft>
-                <a:spcPts val="0"/>
-              </a:spcAft>
-            </a:pPr>
-            <a:r>
-              <a:rPr sz="740" b="0">
-                <a:solidFill>
-                  <a:srgbClr val="68747B"/>
-                </a:solidFill>
-                <a:latin typeface="Arial"/>
-              </a:rPr>
-              <a:t>The cash bridge is a decision aid; populate it with internal Treasury data before asserting an actual funding gap.</a:t>
+              <a:t>UBS, Third-quarter 2011 results and presentation materials, 25 October 2011.</a:t>
             </a:r>
           </a:p>
         </p:txBody>

</xml_diff>